<commit_message>
modified:   .DS_Store 	modified:   Banners.pptx 	modified:   Data/CourseDescriptions.json 	new file:   Data/volunteer courses.json 	new file:   Venues.xlsx 	modified:   index.html 	modified:   script/script.js 	modified:   style/style.css 	deleted:    ~$Banners.pptx
</commit_message>
<xml_diff>
--- a/Banners.pptx
+++ b/Banners.pptx
@@ -8,6 +8,8 @@
     <p:sldId id="256" r:id="rId2"/>
     <p:sldId id="257" r:id="rId3"/>
     <p:sldId id="258" r:id="rId4"/>
+    <p:sldId id="260" r:id="rId5"/>
+    <p:sldId id="259" r:id="rId6"/>
   </p:sldIdLst>
   <p:sldSz cx="18288000" cy="5716588"/>
   <p:notesSz cx="6858000" cy="9144000"/>
@@ -3388,6 +3390,238 @@
 </p:sld>
 </file>
 
+<file path=ppt/slides/slide4.xml><?xml version="1.0" encoding="utf-8"?>
+<p:sld xmlns:a="http://schemas.openxmlformats.org/drawingml/2006/main" xmlns:r="http://schemas.openxmlformats.org/officeDocument/2006/relationships" xmlns:p="http://schemas.openxmlformats.org/presentationml/2006/main">
+  <p:cSld>
+    <p:spTree>
+      <p:nvGrpSpPr>
+        <p:cNvPr id="1" name="">
+          <a:extLst>
+            <a:ext uri="{FF2B5EF4-FFF2-40B4-BE49-F238E27FC236}">
+              <a16:creationId xmlns:a16="http://schemas.microsoft.com/office/drawing/2014/main" id="{128D7280-DC0C-7A11-6F32-D846D3232EE4}"/>
+            </a:ext>
+          </a:extLst>
+        </p:cNvPr>
+        <p:cNvGrpSpPr/>
+        <p:nvPr/>
+      </p:nvGrpSpPr>
+      <p:grpSpPr>
+        <a:xfrm>
+          <a:off x="0" y="0"/>
+          <a:ext cx="0" cy="0"/>
+          <a:chOff x="0" y="0"/>
+          <a:chExt cx="0" cy="0"/>
+        </a:xfrm>
+      </p:grpSpPr>
+      <p:sp>
+        <p:nvSpPr>
+          <p:cNvPr id="6" name="Rectangle 5">
+            <a:extLst>
+              <a:ext uri="{FF2B5EF4-FFF2-40B4-BE49-F238E27FC236}">
+                <a16:creationId xmlns:a16="http://schemas.microsoft.com/office/drawing/2014/main" id="{D50BB31B-0838-EC9E-ABC9-A5EFCCF5827D}"/>
+              </a:ext>
+            </a:extLst>
+          </p:cNvPr>
+          <p:cNvSpPr/>
+          <p:nvPr/>
+        </p:nvSpPr>
+        <p:spPr>
+          <a:xfrm>
+            <a:off x="0" y="0"/>
+            <a:ext cx="18288000" cy="5755177"/>
+          </a:xfrm>
+          <a:prstGeom prst="rect">
+            <a:avLst/>
+          </a:prstGeom>
+          <a:gradFill flip="none" rotWithShape="1">
+            <a:gsLst>
+              <a:gs pos="61000">
+                <a:srgbClr val="0B76A0"/>
+              </a:gs>
+              <a:gs pos="0">
+                <a:schemeClr val="accent4">
+                  <a:lumMod val="75000"/>
+                </a:schemeClr>
+              </a:gs>
+              <a:gs pos="100000">
+                <a:schemeClr val="accent4">
+                  <a:lumMod val="75000"/>
+                  <a:alpha val="0"/>
+                </a:schemeClr>
+              </a:gs>
+            </a:gsLst>
+            <a:lin ang="0" scaled="1"/>
+            <a:tileRect/>
+          </a:gradFill>
+          <a:ln>
+            <a:noFill/>
+          </a:ln>
+        </p:spPr>
+        <p:style>
+          <a:lnRef idx="2">
+            <a:schemeClr val="accent1">
+              <a:shade val="15000"/>
+            </a:schemeClr>
+          </a:lnRef>
+          <a:fillRef idx="1">
+            <a:schemeClr val="accent1"/>
+          </a:fillRef>
+          <a:effectRef idx="0">
+            <a:schemeClr val="accent1"/>
+          </a:effectRef>
+          <a:fontRef idx="minor">
+            <a:schemeClr val="lt1"/>
+          </a:fontRef>
+        </p:style>
+        <p:txBody>
+          <a:bodyPr rtlCol="0" anchor="ctr"/>
+          <a:lstStyle/>
+          <a:p>
+            <a:pPr algn="ctr"/>
+            <a:endParaRPr lang="en-US"/>
+          </a:p>
+        </p:txBody>
+      </p:sp>
+      <p:pic>
+        <p:nvPicPr>
+          <p:cNvPr id="5" name="Picture 4">
+            <a:extLst>
+              <a:ext uri="{FF2B5EF4-FFF2-40B4-BE49-F238E27FC236}">
+                <a16:creationId xmlns:a16="http://schemas.microsoft.com/office/drawing/2014/main" id="{C0F78CE2-FDEF-619E-7D9A-63EE7DDC6267}"/>
+              </a:ext>
+            </a:extLst>
+          </p:cNvPr>
+          <p:cNvPicPr>
+            <a:picLocks noChangeAspect="1"/>
+          </p:cNvPicPr>
+          <p:nvPr/>
+        </p:nvPicPr>
+        <p:blipFill>
+          <a:blip r:embed="rId2"/>
+          <a:srcRect r="22928"/>
+          <a:stretch>
+            <a:fillRect/>
+          </a:stretch>
+        </p:blipFill>
+        <p:spPr>
+          <a:xfrm>
+            <a:off x="8501063" y="304711"/>
+            <a:ext cx="9786937" cy="5145754"/>
+          </a:xfrm>
+          <a:prstGeom prst="rect">
+            <a:avLst/>
+          </a:prstGeom>
+          <a:gradFill>
+            <a:gsLst>
+              <a:gs pos="0">
+                <a:srgbClr val="002060"/>
+              </a:gs>
+              <a:gs pos="100000">
+                <a:srgbClr val="002060">
+                  <a:alpha val="0"/>
+                </a:srgbClr>
+              </a:gs>
+            </a:gsLst>
+            <a:lin ang="0" scaled="1"/>
+          </a:gradFill>
+          <a:effectLst>
+            <a:softEdge rad="188129"/>
+          </a:effectLst>
+        </p:spPr>
+      </p:pic>
+    </p:spTree>
+    <p:extLst>
+      <p:ext uri="{BB962C8B-B14F-4D97-AF65-F5344CB8AC3E}">
+        <p14:creationId xmlns:p14="http://schemas.microsoft.com/office/powerpoint/2010/main" val="3621695373"/>
+      </p:ext>
+    </p:extLst>
+  </p:cSld>
+  <p:clrMapOvr>
+    <a:masterClrMapping/>
+  </p:clrMapOvr>
+</p:sld>
+</file>
+
+<file path=ppt/slides/slide5.xml><?xml version="1.0" encoding="utf-8"?>
+<p:sld xmlns:a="http://schemas.openxmlformats.org/drawingml/2006/main" xmlns:r="http://schemas.openxmlformats.org/officeDocument/2006/relationships" xmlns:p="http://schemas.openxmlformats.org/presentationml/2006/main">
+  <p:cSld>
+    <p:spTree>
+      <p:nvGrpSpPr>
+        <p:cNvPr id="1" name=""/>
+        <p:cNvGrpSpPr/>
+        <p:nvPr/>
+      </p:nvGrpSpPr>
+      <p:grpSpPr>
+        <a:xfrm>
+          <a:off x="0" y="0"/>
+          <a:ext cx="0" cy="0"/>
+          <a:chOff x="0" y="0"/>
+          <a:chExt cx="0" cy="0"/>
+        </a:xfrm>
+      </p:grpSpPr>
+      <p:sp>
+        <p:nvSpPr>
+          <p:cNvPr id="2" name="Title 1">
+            <a:extLst>
+              <a:ext uri="{FF2B5EF4-FFF2-40B4-BE49-F238E27FC236}">
+                <a16:creationId xmlns:a16="http://schemas.microsoft.com/office/drawing/2014/main" id="{B4C23370-79FA-677C-E87C-D576DA632A77}"/>
+              </a:ext>
+            </a:extLst>
+          </p:cNvPr>
+          <p:cNvSpPr>
+            <a:spLocks noGrp="1"/>
+          </p:cNvSpPr>
+          <p:nvPr>
+            <p:ph type="title"/>
+          </p:nvPr>
+        </p:nvSpPr>
+        <p:spPr/>
+        <p:txBody>
+          <a:bodyPr/>
+          <a:lstStyle/>
+          <a:p>
+            <a:endParaRPr lang="en-US"/>
+          </a:p>
+        </p:txBody>
+      </p:sp>
+      <p:sp>
+        <p:nvSpPr>
+          <p:cNvPr id="3" name="Content Placeholder 2">
+            <a:extLst>
+              <a:ext uri="{FF2B5EF4-FFF2-40B4-BE49-F238E27FC236}">
+                <a16:creationId xmlns:a16="http://schemas.microsoft.com/office/drawing/2014/main" id="{9541D697-F3B1-022C-04F1-652F14F9961D}"/>
+              </a:ext>
+            </a:extLst>
+          </p:cNvPr>
+          <p:cNvSpPr>
+            <a:spLocks noGrp="1"/>
+          </p:cNvSpPr>
+          <p:nvPr>
+            <p:ph idx="1"/>
+          </p:nvPr>
+        </p:nvSpPr>
+        <p:spPr/>
+        <p:txBody>
+          <a:bodyPr/>
+          <a:lstStyle/>
+          <a:p>
+            <a:endParaRPr lang="en-US"/>
+          </a:p>
+        </p:txBody>
+      </p:sp>
+    </p:spTree>
+    <p:extLst>
+      <p:ext uri="{BB962C8B-B14F-4D97-AF65-F5344CB8AC3E}">
+        <p14:creationId xmlns:p14="http://schemas.microsoft.com/office/powerpoint/2010/main" val="255383433"/>
+      </p:ext>
+    </p:extLst>
+  </p:cSld>
+  <p:clrMapOvr>
+    <a:masterClrMapping/>
+  </p:clrMapOvr>
+</p:sld>
+</file>
+
 <file path=ppt/theme/theme1.xml><?xml version="1.0" encoding="utf-8"?>
 <a:theme xmlns:a="http://schemas.openxmlformats.org/drawingml/2006/main" name="Office Theme">
   <a:themeElements>

</xml_diff>